<commit_message>
Fix blog PowerPoint delivery and add bilingual blog experience.
Generate EN/ES .pptx for all posts, exclude .pptx from middleware, add Spanish routes and readable blog chrome, and expand Spanish articles to 2000+ words.

Co-authored-by: Cursor <cursoragent@cursor.com>
</commit_message>
<xml_diff>
--- a/public/blog/presentations/18-wheeler-crash-black-box-fmcsa-evidence-2026.pptx
+++ b/public/blog/presentations/18-wheeler-crash-black-box-fmcsa-evidence-2026.pptx
@@ -582,7 +582,7 @@
           <a:lstStyle/>
           <a:p>
             <a:r>
-              <a:t>CTA slide. Phone 855 WRECKMATCH (855) 897-3256. WreckMatch referral service. WreckMatch LLC — legal referral service, not a law firm. Educational only. 800+ participating law firms. Call 855 WRECKMATCH. Reviewed for legal context by Judge Roy Waddell.</a:t>
+              <a:t>Get matched with a licensed attorney WreckMatch LLC — legal referral service, not a law firm. Educational only. 800+ participating law firms. Call 855 WRECKMATCH. Reviewed for legal context by Judge Roy Waddell.</a:t>
             </a:r>
           </a:p>
         </p:txBody>
@@ -652,7 +652,7 @@
           <a:lstStyle/>
           <a:p>
             <a:r>
-              <a:t>Roy Waddell review line mirrors published blog posts. WreckMatch LLC — legal referral service, not a law firm. Educational only. 800+ participating law firms. Call 855 WRECKMATCH. Reviewed for legal context by Judge Roy Waddell.</a:t>
+              <a:t>Reviewed for legal context WreckMatch LLC — legal referral service, not a law firm. Educational only. 800+ participating law firms. Call 855 WRECKMATCH. Reviewed for legal context by Judge Roy Waddell.</a:t>
             </a:r>
           </a:p>
         </p:txBody>
@@ -722,7 +722,7 @@
           <a:lstStyle/>
           <a:p>
             <a:r>
-              <a:t>Compliance slide required for all WreckMatch educational materials. WreckMatch LLC — legal referral service, not a law firm. Educational only. 800+ participating law firms. Call 855 WRECKMATCH. Reviewed for legal context by Judge Roy Waddell.</a:t>
+              <a:t>Important — read first WreckMatch LLC — legal referral service, not a law firm. Educational only. 800+ participating law firms. Call 855 WRECKMATCH. Reviewed for legal context by Judge Roy Waddell.</a:t>
             </a:r>
           </a:p>
         </p:txBody>
@@ -1310,7 +1310,7 @@
           <a:lstStyle/>
           <a:p>
             <a:r>
-              <a:t>Frequently asked questions — FAQ slide for AI citation and search. WreckMatch LLC — legal referral service, not a law firm. Educational only. 800+ participating law firms. Call 855 WRECKMATCH. Reviewed for legal context by Judge Roy Waddell.</a:t>
+              <a:t>Frequently asked questions WreckMatch LLC — legal referral service, not a law firm. Educational only. 800+ participating law firms. Call 855 WRECKMATCH. Reviewed for legal context by Judge Roy Waddell.</a:t>
             </a:r>
           </a:p>
         </p:txBody>
@@ -4778,7 +4778,7 @@
               </a:defRPr>
             </a:pPr>
             <a:r>
-              <a:t>Download companion guide: https://www.wreckmatch.com/blog/18-wheeler-crash-black-box-fmcsa-evidence-2026</a:t>
+              <a:t>Guía: https://www.wreckmatch.com/blog/18-wheeler-crash-black-box-fmcsa-evidence-2026</a:t>
             </a:r>
           </a:p>
         </p:txBody>
@@ -4980,7 +4980,7 @@
               </a:defRPr>
             </a:pPr>
             <a:r>
-              <a:t>Author perspective: Scott Tischler, Co-Founder.</a:t>
+              <a:t>Author: Scott Tischler, Co-Founder.</a:t>
             </a:r>
           </a:p>
         </p:txBody>

</xml_diff>